<commit_message>
Fix pitch step count to distinguish prefill and decode
</commit_message>
<xml_diff>
--- a/Layercake_judges_pitch.pptx
+++ b/Layercake_judges_pitch.pptx
@@ -4869,7 +4869,7 @@
               </a:defRPr>
             </a:pPr>
             <a:r>
-              <a:t>43 output steps  •  3.603 decode steps/s</a:t>
+              <a:t>42 decode steps  •  1 prefill  •  3.603 decode/s</a:t>
             </a:r>
           </a:p>
         </p:txBody>
@@ -5272,7 +5272,7 @@
               </a:defRPr>
             </a:pPr>
             <a:r>
-              <a:t>43</a:t>
+              <a:t>42</a:t>
             </a:r>
           </a:p>
         </p:txBody>
@@ -5308,7 +5308,7 @@
               </a:defRPr>
             </a:pPr>
             <a:r>
-              <a:t>output steps</a:t>
+              <a:t>decode steps</a:t>
             </a:r>
           </a:p>
         </p:txBody>
@@ -5459,7 +5459,7 @@
               </a:defRPr>
             </a:pPr>
             <a:r>
-              <a:t>Measured result for this run; not a general performance benchmark.</a:t>
+              <a:t>1 prefill + 42 decode; run-specific, not a general benchmark.</a:t>
             </a:r>
           </a:p>
         </p:txBody>

</xml_diff>